<commit_message>
Update final report generation and figures
- Changed the markdown file name from 'final-report-v18.md' to 'final-report-v19.md' in the report generation script.
- Updated multiple figures in the report, including changes to the content and structure of the figures related to MLFQ algorithm.
- Adjusted figure dimensions and colors for better clarity and consistency.
- Generated a new final report document reflecting these updates.
</commit_message>
<xml_diff>
--- a/06-final-report/figures/fig-1-algo-concepts.pptx
+++ b/06-final-report/figures/fig-1-algo-concepts.pptx
@@ -2099,7 +2099,7 @@
         <p:spPr>
           <a:xfrm>
             <a:off x="365760" y="3886200"/>
-            <a:ext cx="3474720" cy="320040"/>
+            <a:ext cx="3474720" cy="256032"/>
           </a:xfrm>
           <a:prstGeom prst="rect">
             <a:avLst/>
@@ -2124,7 +2124,7 @@
         <p:spPr>
           <a:xfrm>
             <a:off x="457200" y="3886200"/>
-            <a:ext cx="3383280" cy="320040"/>
+            <a:ext cx="3383280" cy="256032"/>
           </a:xfrm>
           <a:prstGeom prst="rect">
             <a:avLst/>
@@ -2162,8 +2162,8 @@
         </p:nvSpPr>
         <p:spPr>
           <a:xfrm>
-            <a:off x="365760" y="4270248"/>
-            <a:ext cx="2926080" cy="320040"/>
+            <a:off x="365760" y="4187952"/>
+            <a:ext cx="2926080" cy="256032"/>
           </a:xfrm>
           <a:prstGeom prst="rect">
             <a:avLst/>
@@ -2187,8 +2187,8 @@
         </p:nvSpPr>
         <p:spPr>
           <a:xfrm>
-            <a:off x="457200" y="4270248"/>
-            <a:ext cx="2834640" cy="320040"/>
+            <a:off x="457200" y="4187952"/>
+            <a:ext cx="2834640" cy="256032"/>
           </a:xfrm>
           <a:prstGeom prst="rect">
             <a:avLst/>
@@ -2226,14 +2226,14 @@
         </p:nvSpPr>
         <p:spPr>
           <a:xfrm>
-            <a:off x="365760" y="4654296"/>
-            <a:ext cx="2377440" cy="320040"/>
-          </a:xfrm>
-          <a:prstGeom prst="rect">
-            <a:avLst/>
-          </a:prstGeom>
-          <a:solidFill>
-            <a:srgbClr val="CCCCCC"/>
+            <a:off x="365760" y="4489704"/>
+            <a:ext cx="2377440" cy="256032"/>
+          </a:xfrm>
+          <a:prstGeom prst="rect">
+            <a:avLst/>
+          </a:prstGeom>
+          <a:solidFill>
+            <a:srgbClr val="999999"/>
           </a:solidFill>
           <a:ln w="6350">
             <a:solidFill>
@@ -2251,8 +2251,8 @@
         </p:nvSpPr>
         <p:spPr>
           <a:xfrm>
-            <a:off x="457200" y="4654296"/>
-            <a:ext cx="2286000" cy="320040"/>
+            <a:off x="457200" y="4489704"/>
+            <a:ext cx="2286000" cy="256032"/>
           </a:xfrm>
           <a:prstGeom prst="rect">
             <a:avLst/>
@@ -2276,7 +2276,7 @@
                 <a:ea typeface="맑은 고딕" pitchFamily="34" charset="-122"/>
                 <a:cs typeface="맑은 고딕" pitchFamily="34" charset="-120"/>
               </a:rPr>
-              <a:t>Q2 (무제한)</a:t>
+              <a:t>Q2 (8초 할당)</a:t>
             </a:r>
             <a:endParaRPr lang="en-US" sz="800" dirty="0"/>
           </a:p>
@@ -2285,6 +2285,70 @@
       <p:sp>
         <p:nvSpPr>
           <p:cNvPr id="44" name="Shape 42"/>
+          <p:cNvSpPr/>
+          <p:nvPr/>
+        </p:nvSpPr>
+        <p:spPr>
+          <a:xfrm>
+            <a:off x="365760" y="4791456"/>
+            <a:ext cx="1828800" cy="256032"/>
+          </a:xfrm>
+          <a:prstGeom prst="rect">
+            <a:avLst/>
+          </a:prstGeom>
+          <a:solidFill>
+            <a:srgbClr val="CCCCCC"/>
+          </a:solidFill>
+          <a:ln w="6350">
+            <a:solidFill>
+              <a:srgbClr val="000000"/>
+            </a:solidFill>
+            <a:prstDash val="solid"/>
+          </a:ln>
+        </p:spPr>
+      </p:sp>
+      <p:sp>
+        <p:nvSpPr>
+          <p:cNvPr id="45" name="Text 43"/>
+          <p:cNvSpPr/>
+          <p:nvPr/>
+        </p:nvSpPr>
+        <p:spPr>
+          <a:xfrm>
+            <a:off x="457200" y="4791456"/>
+            <a:ext cx="1737360" cy="256032"/>
+          </a:xfrm>
+          <a:prstGeom prst="rect">
+            <a:avLst/>
+          </a:prstGeom>
+          <a:noFill/>
+          <a:ln/>
+        </p:spPr>
+        <p:txBody>
+          <a:bodyPr wrap="square" rtlCol="0" anchor="ctr"/>
+          <a:lstStyle/>
+          <a:p>
+            <a:pPr indent="0" marL="0">
+              <a:buNone/>
+            </a:pPr>
+            <a:r>
+              <a:rPr lang="en-US" sz="800" dirty="0">
+                <a:solidFill>
+                  <a:srgbClr val="000000"/>
+                </a:solidFill>
+                <a:latin typeface="맑은 고딕" pitchFamily="34" charset="0"/>
+                <a:ea typeface="맑은 고딕" pitchFamily="34" charset="-122"/>
+                <a:cs typeface="맑은 고딕" pitchFamily="34" charset="-120"/>
+              </a:rPr>
+              <a:t>Q3 (무제한)</a:t>
+            </a:r>
+            <a:endParaRPr lang="en-US" sz="800" dirty="0"/>
+          </a:p>
+        </p:txBody>
+      </p:sp>
+      <p:sp>
+        <p:nvSpPr>
+          <p:cNvPr id="46" name="Shape 44"/>
           <p:cNvSpPr/>
           <p:nvPr/>
         </p:nvSpPr>
@@ -2309,7 +2373,7 @@
       </p:sp>
       <p:sp>
         <p:nvSpPr>
-          <p:cNvPr id="45" name="Shape 43"/>
+          <p:cNvPr id="47" name="Shape 45"/>
           <p:cNvSpPr/>
           <p:nvPr/>
         </p:nvSpPr>
@@ -2334,7 +2398,7 @@
       </p:sp>
       <p:sp>
         <p:nvSpPr>
-          <p:cNvPr id="46" name="Text 44"/>
+          <p:cNvPr id="48" name="Text 46"/>
           <p:cNvSpPr/>
           <p:nvPr/>
         </p:nvSpPr>
@@ -2373,7 +2437,7 @@
       </p:sp>
       <p:sp>
         <p:nvSpPr>
-          <p:cNvPr id="47" name="Shape 45"/>
+          <p:cNvPr id="49" name="Shape 47"/>
           <p:cNvSpPr/>
           <p:nvPr/>
         </p:nvSpPr>
@@ -2398,7 +2462,7 @@
       </p:sp>
       <p:sp>
         <p:nvSpPr>
-          <p:cNvPr id="48" name="Text 46"/>
+          <p:cNvPr id="50" name="Text 48"/>
           <p:cNvSpPr/>
           <p:nvPr/>
         </p:nvSpPr>
@@ -2437,7 +2501,7 @@
       </p:sp>
       <p:sp>
         <p:nvSpPr>
-          <p:cNvPr id="49" name="Text 47"/>
+          <p:cNvPr id="51" name="Text 49"/>
           <p:cNvSpPr/>
           <p:nvPr/>
         </p:nvSpPr>
@@ -2476,7 +2540,7 @@
       </p:sp>
       <p:sp>
         <p:nvSpPr>
-          <p:cNvPr id="50" name="Text 48"/>
+          <p:cNvPr id="52" name="Text 50"/>
           <p:cNvSpPr/>
           <p:nvPr/>
         </p:nvSpPr>
@@ -2515,7 +2579,7 @@
       </p:sp>
       <p:sp>
         <p:nvSpPr>
-          <p:cNvPr id="51" name="Shape 49"/>
+          <p:cNvPr id="53" name="Shape 51"/>
           <p:cNvSpPr/>
           <p:nvPr/>
         </p:nvSpPr>
@@ -2540,7 +2604,7 @@
       </p:sp>
       <p:sp>
         <p:nvSpPr>
-          <p:cNvPr id="52" name="Text 50"/>
+          <p:cNvPr id="54" name="Text 52"/>
           <p:cNvSpPr/>
           <p:nvPr/>
         </p:nvSpPr>
@@ -2579,7 +2643,7 @@
       </p:sp>
       <p:sp>
         <p:nvSpPr>
-          <p:cNvPr id="53" name="Shape 51"/>
+          <p:cNvPr id="55" name="Shape 53"/>
           <p:cNvSpPr/>
           <p:nvPr/>
         </p:nvSpPr>
@@ -2604,7 +2668,7 @@
       </p:sp>
       <p:sp>
         <p:nvSpPr>
-          <p:cNvPr id="54" name="Text 52"/>
+          <p:cNvPr id="56" name="Text 54"/>
           <p:cNvSpPr/>
           <p:nvPr/>
         </p:nvSpPr>
@@ -2643,7 +2707,7 @@
       </p:sp>
       <p:sp>
         <p:nvSpPr>
-          <p:cNvPr id="55" name="Shape 53"/>
+          <p:cNvPr id="57" name="Shape 55"/>
           <p:cNvSpPr/>
           <p:nvPr/>
         </p:nvSpPr>
@@ -2668,7 +2732,7 @@
       </p:sp>
       <p:sp>
         <p:nvSpPr>
-          <p:cNvPr id="56" name="Text 54"/>
+          <p:cNvPr id="58" name="Text 56"/>
           <p:cNvSpPr/>
           <p:nvPr/>
         </p:nvSpPr>
@@ -2707,7 +2771,7 @@
       </p:sp>
       <p:sp>
         <p:nvSpPr>
-          <p:cNvPr id="57" name="Shape 55"/>
+          <p:cNvPr id="59" name="Shape 57"/>
           <p:cNvSpPr/>
           <p:nvPr/>
         </p:nvSpPr>
@@ -2732,7 +2796,7 @@
       </p:sp>
       <p:sp>
         <p:nvSpPr>
-          <p:cNvPr id="58" name="Text 56"/>
+          <p:cNvPr id="60" name="Text 58"/>
           <p:cNvSpPr/>
           <p:nvPr/>
         </p:nvSpPr>
@@ -2771,7 +2835,7 @@
       </p:sp>
       <p:sp>
         <p:nvSpPr>
-          <p:cNvPr id="59" name="Shape 57"/>
+          <p:cNvPr id="61" name="Shape 59"/>
           <p:cNvSpPr/>
           <p:nvPr/>
         </p:nvSpPr>
@@ -2796,7 +2860,7 @@
       </p:sp>
       <p:sp>
         <p:nvSpPr>
-          <p:cNvPr id="60" name="Shape 58"/>
+          <p:cNvPr id="62" name="Shape 60"/>
           <p:cNvSpPr/>
           <p:nvPr/>
         </p:nvSpPr>

</xml_diff>

<commit_message>
Add new figures package and multiple final report documents
- Created a new package.json for the figures directory with dependencies on playwright, pptxgenjs, and sharp.
- Added several new final report documents in different snapshots, including:
- final-report.docx (snapshot from 20260415)
- final-report.docx (snapshot from 20260415, 175615)
- final-report-v17-pre.docx (snapshot from 20260416, 101147)
- final-report-v19.docx (snapshot from 20260416, 144229)
- final-report-v21.docx (snapshot from 20260416, 184732)
</commit_message>
<xml_diff>
--- a/06-final-report/figures/fig-1-algo-concepts.pptx
+++ b/06-final-report/figures/fig-1-algo-concepts.pptx
@@ -1530,7 +1530,7 @@
                 <a:ea typeface="맑은 고딕" pitchFamily="34" charset="-122"/>
                 <a:cs typeface="맑은 고딕" pitchFamily="34" charset="-120"/>
               </a:rPr>
-              <a:t>(URG &gt; HIGH &gt; NORM &gt; LOW)</a:t>
+              <a:t>(URGENT &gt; HIGH &gt; NORMAL &gt; LOW)</a:t>
             </a:r>
             <a:endParaRPr lang="en-US" sz="900" dirty="0"/>
           </a:p>
@@ -1594,7 +1594,7 @@
                 <a:ea typeface="맑은 고딕" pitchFamily="34" charset="-122"/>
                 <a:cs typeface="맑은 고딕" pitchFamily="34" charset="-120"/>
               </a:rPr>
-              <a:t>URG</a:t>
+              <a:t>URGENT</a:t>
             </a:r>
             <a:endParaRPr lang="en-US" sz="900" dirty="0"/>
           </a:p>
@@ -1800,7 +1800,7 @@
                 <a:ea typeface="맑은 고딕" pitchFamily="34" charset="-122"/>
                 <a:cs typeface="맑은 고딕" pitchFamily="34" charset="-120"/>
               </a:rPr>
-              <a:t>NORM</a:t>
+              <a:t>NORMAL</a:t>
             </a:r>
             <a:endParaRPr lang="en-US" sz="900" dirty="0"/>
           </a:p>

</xml_diff>